<commit_message>
v6: Consumer Voice 50pt + cards cuali 15×6cm (567×227pt) en los 3 pilares
Feedback Jeremy 15-may-2026:
- Consumer Voice verbatim: 60pt → 50pt (Instrument Serif)
- Cards cualitativas: 549×221pt → 567×227pt = 15×6cm (medido en centímetros)
- Re-organización de Opiniones Políticas build_cuali_slide: cards side by side (era stack vertical con card grande 1637pt)
- aprendizajes-montador-cc.md actualizado con bloque V6 explícito
</commit_message>
<xml_diff>
--- a/Agentes Hallazgos/mujer-v2-deck-flat.pptx
+++ b/Agentes Hallazgos/mujer-v2-deck-flat.pptx
@@ -3318,7 +3318,7 @@
           <a:p>
             <a:pPr algn="ctr"/>
             <a:r>
-              <a:rPr sz="6000" b="0" i="0" kern="0" spc="0">
+              <a:rPr sz="5000" b="0" i="0" kern="0" spc="0">
                 <a:solidFill>
                   <a:srgbClr val="FFFFFF"/>
                 </a:solidFill>
@@ -3869,7 +3869,7 @@
           <a:p>
             <a:pPr algn="ctr"/>
             <a:r>
-              <a:rPr sz="6000" b="0" i="0" kern="0" spc="0">
+              <a:rPr sz="5000" b="0" i="0" kern="0" spc="0">
                 <a:solidFill>
                   <a:srgbClr val="FFFFFF"/>
                 </a:solidFill>
@@ -4551,7 +4551,7 @@
           <a:p>
             <a:pPr algn="ctr"/>
             <a:r>
-              <a:rPr sz="6000" b="0" i="0" kern="0" spc="0">
+              <a:rPr sz="5000" b="0" i="0" kern="0" spc="0">
                 <a:solidFill>
                   <a:srgbClr val="FFFFFF"/>
                 </a:solidFill>
@@ -5095,8 +5095,8 @@
         </p:nvSpPr>
         <p:spPr>
           <a:xfrm>
-            <a:off x="3533775" y="4086225"/>
-            <a:ext cx="5229225" cy="2105025"/>
+            <a:off x="3362325" y="4086225"/>
+            <a:ext cx="5400675" cy="2162175"/>
           </a:xfrm>
           <a:prstGeom prst="roundRect">
             <a:avLst>
@@ -5144,8 +5144,8 @@
         </p:nvSpPr>
         <p:spPr>
           <a:xfrm>
-            <a:off x="3819525" y="4324350"/>
-            <a:ext cx="4657725" cy="1628775"/>
+            <a:off x="3648075" y="4324350"/>
+            <a:ext cx="4829175" cy="1685925"/>
           </a:xfrm>
           <a:prstGeom prst="rect">
             <a:avLst/>
@@ -5196,7 +5196,7 @@
         <p:spPr>
           <a:xfrm>
             <a:off x="9525000" y="4086225"/>
-            <a:ext cx="5229225" cy="2105025"/>
+            <a:ext cx="5400675" cy="2162175"/>
           </a:xfrm>
           <a:prstGeom prst="roundRect">
             <a:avLst>
@@ -5245,7 +5245,7 @@
         <p:spPr>
           <a:xfrm>
             <a:off x="9810750" y="4324350"/>
-            <a:ext cx="4657725" cy="1628775"/>
+            <a:ext cx="4829175" cy="1685925"/>
           </a:xfrm>
           <a:prstGeom prst="rect">
             <a:avLst/>
@@ -6343,7 +6343,7 @@
           <a:p>
             <a:pPr algn="ctr"/>
             <a:r>
-              <a:rPr sz="6000" b="0" i="0" kern="0" spc="0">
+              <a:rPr sz="5000" b="0" i="0" kern="0" spc="0">
                 <a:solidFill>
                   <a:srgbClr val="FFFFFF"/>
                 </a:solidFill>
@@ -6894,7 +6894,7 @@
           <a:p>
             <a:pPr algn="ctr"/>
             <a:r>
-              <a:rPr sz="6000" b="0" i="0" kern="0" spc="0">
+              <a:rPr sz="5000" b="0" i="0" kern="0" spc="0">
                 <a:solidFill>
                   <a:srgbClr val="FFFFFF"/>
                 </a:solidFill>
@@ -7445,7 +7445,7 @@
           <a:p>
             <a:pPr algn="ctr"/>
             <a:r>
-              <a:rPr sz="6000" b="0" i="0" kern="0" spc="0">
+              <a:rPr sz="5000" b="0" i="0" kern="0" spc="0">
                 <a:solidFill>
                   <a:srgbClr val="FFFFFF"/>
                 </a:solidFill>
@@ -7727,8 +7727,8 @@
         </p:nvSpPr>
         <p:spPr>
           <a:xfrm>
-            <a:off x="3533775" y="4086225"/>
-            <a:ext cx="5229225" cy="2105025"/>
+            <a:off x="3362325" y="4086225"/>
+            <a:ext cx="5400675" cy="2162175"/>
           </a:xfrm>
           <a:prstGeom prst="roundRect">
             <a:avLst>
@@ -7776,8 +7776,8 @@
         </p:nvSpPr>
         <p:spPr>
           <a:xfrm>
-            <a:off x="3819525" y="4324350"/>
-            <a:ext cx="4657725" cy="1628775"/>
+            <a:off x="3648075" y="4324350"/>
+            <a:ext cx="4829175" cy="1685925"/>
           </a:xfrm>
           <a:prstGeom prst="rect">
             <a:avLst/>
@@ -7828,7 +7828,7 @@
         <p:spPr>
           <a:xfrm>
             <a:off x="9525000" y="4086225"/>
-            <a:ext cx="5229225" cy="2105025"/>
+            <a:ext cx="5400675" cy="2162175"/>
           </a:xfrm>
           <a:prstGeom prst="roundRect">
             <a:avLst>
@@ -7877,7 +7877,7 @@
         <p:spPr>
           <a:xfrm>
             <a:off x="9810750" y="4324350"/>
-            <a:ext cx="4657725" cy="1628775"/>
+            <a:ext cx="4829175" cy="1685925"/>
           </a:xfrm>
           <a:prstGeom prst="rect">
             <a:avLst/>
@@ -8555,7 +8555,7 @@
           <a:p>
             <a:pPr algn="ctr"/>
             <a:r>
-              <a:rPr sz="6000" b="0" i="0" kern="0" spc="0">
+              <a:rPr sz="5000" b="0" i="0" kern="0" spc="0">
                 <a:solidFill>
                   <a:srgbClr val="FFFFFF"/>
                 </a:solidFill>
@@ -8686,7 +8686,7 @@
           <a:p>
             <a:pPr algn="ctr"/>
             <a:r>
-              <a:rPr sz="6000" b="0" i="0" kern="0" spc="0">
+              <a:rPr sz="5000" b="0" i="0" kern="0" spc="0">
                 <a:solidFill>
                   <a:srgbClr val="FFFFFF"/>
                 </a:solidFill>
@@ -9237,7 +9237,7 @@
           <a:p>
             <a:pPr algn="ctr"/>
             <a:r>
-              <a:rPr sz="6000" b="0" i="0" kern="0" spc="0">
+              <a:rPr sz="5000" b="0" i="0" kern="0" spc="0">
                 <a:solidFill>
                   <a:srgbClr val="FFFFFF"/>
                 </a:solidFill>
@@ -9781,8 +9781,8 @@
         </p:nvSpPr>
         <p:spPr>
           <a:xfrm>
-            <a:off x="3533775" y="4086225"/>
-            <a:ext cx="5229225" cy="2105025"/>
+            <a:off x="3362325" y="4086225"/>
+            <a:ext cx="5400675" cy="2162175"/>
           </a:xfrm>
           <a:prstGeom prst="roundRect">
             <a:avLst>
@@ -9830,8 +9830,8 @@
         </p:nvSpPr>
         <p:spPr>
           <a:xfrm>
-            <a:off x="3819525" y="4324350"/>
-            <a:ext cx="4657725" cy="1628775"/>
+            <a:off x="3648075" y="4324350"/>
+            <a:ext cx="4829175" cy="1685925"/>
           </a:xfrm>
           <a:prstGeom prst="rect">
             <a:avLst/>
@@ -9882,7 +9882,7 @@
         <p:spPr>
           <a:xfrm>
             <a:off x="9525000" y="4086225"/>
-            <a:ext cx="5229225" cy="2105025"/>
+            <a:ext cx="5400675" cy="2162175"/>
           </a:xfrm>
           <a:prstGeom prst="roundRect">
             <a:avLst>
@@ -9931,7 +9931,7 @@
         <p:spPr>
           <a:xfrm>
             <a:off x="9810750" y="4324350"/>
-            <a:ext cx="4657725" cy="1628775"/>
+            <a:ext cx="4829175" cy="1685925"/>
           </a:xfrm>
           <a:prstGeom prst="rect">
             <a:avLst/>
@@ -10478,7 +10478,7 @@
           <a:p>
             <a:pPr algn="ctr"/>
             <a:r>
-              <a:rPr sz="6000" b="0" i="0" kern="0" spc="0">
+              <a:rPr sz="5000" b="0" i="0" kern="0" spc="0">
                 <a:solidFill>
                   <a:srgbClr val="FFFFFF"/>
                 </a:solidFill>
@@ -11029,7 +11029,7 @@
           <a:p>
             <a:pPr algn="ctr"/>
             <a:r>
-              <a:rPr sz="6000" b="0" i="0" kern="0" spc="0">
+              <a:rPr sz="5000" b="0" i="0" kern="0" spc="0">
                 <a:solidFill>
                   <a:srgbClr val="FFFFFF"/>
                 </a:solidFill>

</xml_diff>

<commit_message>
Editor v6 anti-AI: auditoría 3 pilares + SOURCE en Mujer
Patrones eliminados:
- 'No es X, es Y' (~12 ocurrencias entre los 3 pilares)
- 'imaginario'/'chip'/'narrativa' como muletillas repetidas
- 'tener nombre de mujer', 'X no se enteró', 'la realidad cambió, X no'
- Sobre-explicación post-stat ('Esto demuestra que...', 'Lo que está en juego es...')

3 pilares actualizados:
- mujer-v2: headlines + stats limpios, SOURCE al pie de cada slide (CC o FW, sin mencionar Banreservas)
- sistema-creencias: H10 entre otros, formula 'no es X es Y' eliminada
- opiniones-politicas: 9 headlines reescritos

aprendizajes-editor-cc.md actualizado con sección 7.bis (refuerzo crítico) y 7.ter (lista negra expandida)
</commit_message>
<xml_diff>
--- a/Agentes Hallazgos/mujer-v2-deck-flat.pptx
+++ b/Agentes Hallazgos/mujer-v2-deck-flat.pptx
@@ -3364,6 +3364,41 @@
           </a:p>
         </p:txBody>
       </p:sp>
+      <p:sp>
+        <p:nvSpPr>
+          <p:cNvPr id="5" name="TextBox 4"/>
+          <p:cNvSpPr txBox="1"/>
+          <p:nvPr/>
+        </p:nvSpPr>
+        <p:spPr>
+          <a:xfrm>
+            <a:off x="0" y="9620250"/>
+            <a:ext cx="18288000" cy="476250"/>
+          </a:xfrm>
+          <a:prstGeom prst="rect">
+            <a:avLst/>
+          </a:prstGeom>
+          <a:noFill/>
+        </p:spPr>
+        <p:txBody>
+          <a:bodyPr wrap="square" lIns="0" rIns="0" tIns="0" bIns="0">
+            <a:spAutoFit/>
+          </a:bodyPr>
+          <a:lstStyle/>
+          <a:p>
+            <a:pPr algn="ctr"/>
+            <a:r>
+              <a:rPr sz="1200" b="0" i="1" kern="0" spc="0">
+                <a:solidFill>
+                  <a:srgbClr val="9B9B9B"/>
+                </a:solidFill>
+                <a:latin typeface="Poppins"/>
+              </a:rPr>
+              <a:t>Source: Código Casa — Pilar Mujer · Q057, Q056 · Base 500.</a:t>
+            </a:r>
+          </a:p>
+        </p:txBody>
+      </p:sp>
     </p:spTree>
   </p:cSld>
   <p:clrMapOvr>
@@ -3784,6 +3819,41 @@
           </a:p>
         </p:txBody>
       </p:sp>
+      <p:sp>
+        <p:nvSpPr>
+          <p:cNvPr id="11" name="TextBox 10"/>
+          <p:cNvSpPr txBox="1"/>
+          <p:nvPr/>
+        </p:nvSpPr>
+        <p:spPr>
+          <a:xfrm>
+            <a:off x="0" y="9620250"/>
+            <a:ext cx="18288000" cy="476250"/>
+          </a:xfrm>
+          <a:prstGeom prst="rect">
+            <a:avLst/>
+          </a:prstGeom>
+          <a:noFill/>
+        </p:spPr>
+        <p:txBody>
+          <a:bodyPr wrap="square" lIns="0" rIns="0" tIns="0" bIns="0">
+            <a:spAutoFit/>
+          </a:bodyPr>
+          <a:lstStyle/>
+          <a:p>
+            <a:pPr algn="ctr"/>
+            <a:r>
+              <a:rPr sz="1200" b="0" i="1" kern="0" spc="0">
+                <a:solidFill>
+                  <a:srgbClr val="9B9B9B"/>
+                </a:solidFill>
+                <a:latin typeface="Poppins"/>
+              </a:rPr>
+              <a:t>Source: Código Casa — Pilar Mujer · Q059 · Base 500.</a:t>
+            </a:r>
+          </a:p>
+        </p:txBody>
+      </p:sp>
     </p:spTree>
   </p:cSld>
   <p:clrMapOvr>
@@ -3915,6 +3985,41 @@
           </a:p>
         </p:txBody>
       </p:sp>
+      <p:sp>
+        <p:nvSpPr>
+          <p:cNvPr id="5" name="TextBox 4"/>
+          <p:cNvSpPr txBox="1"/>
+          <p:nvPr/>
+        </p:nvSpPr>
+        <p:spPr>
+          <a:xfrm>
+            <a:off x="0" y="9620250"/>
+            <a:ext cx="18288000" cy="476250"/>
+          </a:xfrm>
+          <a:prstGeom prst="rect">
+            <a:avLst/>
+          </a:prstGeom>
+          <a:noFill/>
+        </p:spPr>
+        <p:txBody>
+          <a:bodyPr wrap="square" lIns="0" rIns="0" tIns="0" bIns="0">
+            <a:spAutoFit/>
+          </a:bodyPr>
+          <a:lstStyle/>
+          <a:p>
+            <a:pPr algn="ctr"/>
+            <a:r>
+              <a:rPr sz="1200" b="0" i="1" kern="0" spc="0">
+                <a:solidFill>
+                  <a:srgbClr val="9B9B9B"/>
+                </a:solidFill>
+                <a:latin typeface="Poppins"/>
+              </a:rPr>
+              <a:t>Source: Código Casa — Pilar Mujer · Q059 · Base 500.</a:t>
+            </a:r>
+          </a:p>
+        </p:txBody>
+      </p:sp>
     </p:spTree>
   </p:cSld>
   <p:clrMapOvr>
@@ -4041,7 +4146,7 @@
                 </a:solidFill>
                 <a:latin typeface="Poppins"/>
               </a:rPr>
-              <a:t>La mujer decide qué se come y también quién provee. El imaginario no lo reconoce todavía.</a:t>
+              <a:t>La mujer decide qué se come y también quién provee. El discurso social tarda en reconocerlo.</a:t>
             </a:r>
           </a:p>
         </p:txBody>
@@ -4466,6 +4571,41 @@
           </a:p>
         </p:txBody>
       </p:sp>
+      <p:sp>
+        <p:nvSpPr>
+          <p:cNvPr id="11" name="TextBox 10"/>
+          <p:cNvSpPr txBox="1"/>
+          <p:nvPr/>
+        </p:nvSpPr>
+        <p:spPr>
+          <a:xfrm>
+            <a:off x="0" y="9620250"/>
+            <a:ext cx="18288000" cy="476250"/>
+          </a:xfrm>
+          <a:prstGeom prst="rect">
+            <a:avLst/>
+          </a:prstGeom>
+          <a:noFill/>
+        </p:spPr>
+        <p:txBody>
+          <a:bodyPr wrap="square" lIns="0" rIns="0" tIns="0" bIns="0">
+            <a:spAutoFit/>
+          </a:bodyPr>
+          <a:lstStyle/>
+          <a:p>
+            <a:pPr algn="ctr"/>
+            <a:r>
+              <a:rPr sz="1200" b="0" i="1" kern="0" spc="0">
+                <a:solidFill>
+                  <a:srgbClr val="9B9B9B"/>
+                </a:solidFill>
+                <a:latin typeface="Poppins"/>
+              </a:rPr>
+              <a:t>Source: Código Casa — Pilar Mujer · Q058 · Base 500.</a:t>
+            </a:r>
+          </a:p>
+        </p:txBody>
+      </p:sp>
     </p:spTree>
   </p:cSld>
   <p:clrMapOvr>
@@ -4597,6 +4737,41 @@
           </a:p>
         </p:txBody>
       </p:sp>
+      <p:sp>
+        <p:nvSpPr>
+          <p:cNvPr id="5" name="TextBox 4"/>
+          <p:cNvSpPr txBox="1"/>
+          <p:nvPr/>
+        </p:nvSpPr>
+        <p:spPr>
+          <a:xfrm>
+            <a:off x="0" y="9620250"/>
+            <a:ext cx="18288000" cy="476250"/>
+          </a:xfrm>
+          <a:prstGeom prst="rect">
+            <a:avLst/>
+          </a:prstGeom>
+          <a:noFill/>
+        </p:spPr>
+        <p:txBody>
+          <a:bodyPr wrap="square" lIns="0" rIns="0" tIns="0" bIns="0">
+            <a:spAutoFit/>
+          </a:bodyPr>
+          <a:lstStyle/>
+          <a:p>
+            <a:pPr algn="ctr"/>
+            <a:r>
+              <a:rPr sz="1200" b="0" i="1" kern="0" spc="0">
+                <a:solidFill>
+                  <a:srgbClr val="9B9B9B"/>
+                </a:solidFill>
+                <a:latin typeface="Poppins"/>
+              </a:rPr>
+              <a:t>Source: Código Casa — Pilar Mujer · Q058 · Base 500.</a:t>
+            </a:r>
+          </a:p>
+        </p:txBody>
+      </p:sp>
     </p:spTree>
   </p:cSld>
   <p:clrMapOvr>
@@ -4662,7 +4837,7 @@
                 </a:solidFill>
                 <a:latin typeface="Instrument Serif"/>
               </a:rPr>
-              <a:t>EL IMAGINARIO SIGUE SIENDO DEL HOMBRE: LA REALIDAD CAMBIÓ, EL CHIP NO.</a:t>
+              <a:t>40% PROVEE. EL ROL QUE SE LE ATRIBUYE AL HOMBRE LO OCUPA ELLA.</a:t>
             </a:r>
           </a:p>
         </p:txBody>
@@ -5013,6 +5188,41 @@
                 <a:latin typeface="Poppins"/>
               </a:rPr>
               <a:t>" es la frase con mayor acuerdo top-2 en decisiones financieras (μ=3.01). "No las tomo yo, lo hace mi esposo" tiene el mayor desacuerdo (bottom-2 79.6%).</a:t>
+            </a:r>
+          </a:p>
+        </p:txBody>
+      </p:sp>
+      <p:sp>
+        <p:nvSpPr>
+          <p:cNvPr id="11" name="TextBox 10"/>
+          <p:cNvSpPr txBox="1"/>
+          <p:nvPr/>
+        </p:nvSpPr>
+        <p:spPr>
+          <a:xfrm>
+            <a:off x="0" y="9620250"/>
+            <a:ext cx="18288000" cy="476250"/>
+          </a:xfrm>
+          <a:prstGeom prst="rect">
+            <a:avLst/>
+          </a:prstGeom>
+          <a:noFill/>
+        </p:spPr>
+        <p:txBody>
+          <a:bodyPr wrap="square" lIns="0" rIns="0" tIns="0" bIns="0">
+            <a:spAutoFit/>
+          </a:bodyPr>
+          <a:lstStyle/>
+          <a:p>
+            <a:pPr algn="ctr"/>
+            <a:r>
+              <a:rPr sz="1200" b="0" i="1" kern="0" spc="0">
+                <a:solidFill>
+                  <a:srgbClr val="9B9B9B"/>
+                </a:solidFill>
+                <a:latin typeface="Poppins"/>
+              </a:rPr>
+              <a:t>Source: Finance Women — Estudio cuantitativo 2025 · M8, M5, M17 · Mujeres n=240.</a:t>
             </a:r>
           </a:p>
         </p:txBody>
@@ -5073,7 +5283,7 @@
                 </a:solidFill>
                 <a:latin typeface="Instrument Serif"/>
               </a:rPr>
-              <a:t>EL IMAGINARIO DEL PROVEEDOR NO CEDIÓ. </a:t>
+              <a:t>EL DISCURSO DEL PROVEEDOR NO CEDIÓ. </a:t>
             </a:r>
             <a:r>
               <a:rPr sz="5000" b="0" i="1" kern="0" spc="0">
@@ -5082,7 +5292,7 @@
                 </a:solidFill>
                 <a:latin typeface="Instrument Serif"/>
               </a:rPr>
-              <a:t>ELLAS PROVEEN, EL ROL SIGUE SIENDO DEL HOMBRE EN EL DISCURSO.</a:t>
+              <a:t>ELLAS PROVEEN, EL ROL SIGUE SIENDO DEL HOMBRE EN EL CUENTO SOCIAL.</a:t>
             </a:r>
           </a:p>
         </p:txBody>
@@ -5283,6 +5493,41 @@
                 <a:latin typeface="Poppins"/>
               </a:rPr>
               <a:t>— Familia Masivo Jefas de Hogar</a:t>
+            </a:r>
+          </a:p>
+        </p:txBody>
+      </p:sp>
+      <p:sp>
+        <p:nvSpPr>
+          <p:cNvPr id="7" name="TextBox 6"/>
+          <p:cNvSpPr txBox="1"/>
+          <p:nvPr/>
+        </p:nvSpPr>
+        <p:spPr>
+          <a:xfrm>
+            <a:off x="0" y="9620250"/>
+            <a:ext cx="18288000" cy="476250"/>
+          </a:xfrm>
+          <a:prstGeom prst="rect">
+            <a:avLst/>
+          </a:prstGeom>
+          <a:noFill/>
+        </p:spPr>
+        <p:txBody>
+          <a:bodyPr wrap="square" lIns="0" rIns="0" tIns="0" bIns="0">
+            <a:spAutoFit/>
+          </a:bodyPr>
+          <a:lstStyle/>
+          <a:p>
+            <a:pPr algn="ctr"/>
+            <a:r>
+              <a:rPr sz="1200" b="0" i="1" kern="0" spc="0">
+                <a:solidFill>
+                  <a:srgbClr val="9B9B9B"/>
+                </a:solidFill>
+                <a:latin typeface="Poppins"/>
+              </a:rPr>
+              <a:t>Source: Finance Women — Estudio cuantitativo 2025 · M8, M5, M17 · Mujeres n=240.</a:t>
             </a:r>
           </a:p>
         </p:txBody>
@@ -5483,7 +5728,7 @@
                 </a:solidFill>
                 <a:latin typeface="Instrument Serif"/>
               </a:rPr>
-              <a:t>EL SUEÑO NO ES CONSUMO — ES NO DEPENDER DEL PRÓXIMO SUELDO.</a:t>
+              <a:t>EL SUEÑO ES NO DEPENDER DEL PRÓXIMO SUELDO.</a:t>
             </a:r>
           </a:p>
         </p:txBody>
@@ -5834,6 +6079,41 @@
                 <a:latin typeface="Poppins"/>
               </a:rPr>
               <a:t>" queda último o penúltimo en ambas selecciones (13.8% y 2.1%). El prejuicio de la mujer que sueña con consumo estético no aguanta la data.</a:t>
+            </a:r>
+          </a:p>
+        </p:txBody>
+      </p:sp>
+      <p:sp>
+        <p:nvSpPr>
+          <p:cNvPr id="11" name="TextBox 10"/>
+          <p:cNvSpPr txBox="1"/>
+          <p:nvPr/>
+        </p:nvSpPr>
+        <p:spPr>
+          <a:xfrm>
+            <a:off x="0" y="9620250"/>
+            <a:ext cx="18288000" cy="476250"/>
+          </a:xfrm>
+          <a:prstGeom prst="rect">
+            <a:avLst/>
+          </a:prstGeom>
+          <a:noFill/>
+        </p:spPr>
+        <p:txBody>
+          <a:bodyPr wrap="square" lIns="0" rIns="0" tIns="0" bIns="0">
+            <a:spAutoFit/>
+          </a:bodyPr>
+          <a:lstStyle/>
+          <a:p>
+            <a:pPr algn="ctr"/>
+            <a:r>
+              <a:rPr sz="1200" b="0" i="1" kern="0" spc="0">
+                <a:solidFill>
+                  <a:srgbClr val="9B9B9B"/>
+                </a:solidFill>
+                <a:latin typeface="Poppins"/>
+              </a:rPr>
+              <a:t>Source: Finance Women — Estudio cuantitativo 2025 · M20, M21 · Mujeres n=240.</a:t>
             </a:r>
           </a:p>
         </p:txBody>
@@ -5894,7 +6174,7 @@
                 </a:solidFill>
                 <a:latin typeface="Instrument Serif"/>
               </a:rPr>
-              <a:t>LA CRIANZA TIENE NOMBRE DE MUJER. LAS MUJERES MISMAS LO CONFIRMAN: </a:t>
+              <a:t>49.5% DE LAS MUJERES DICE QUE LA MADRE ES LA PRINCIPAL RESPONSABLE DE LA CRIANZA. </a:t>
             </a:r>
             <a:r>
               <a:rPr sz="5000" b="0" i="1" kern="0" spc="0">
@@ -5903,7 +6183,7 @@
                 </a:solidFill>
                 <a:latin typeface="Instrument Serif"/>
               </a:rPr>
-              <a:t>49.5% DICE QUE LA MADRE ES LA PRINCIPAL RESPONSABLE, NO AMBOS PADRES.</a:t>
+              <a:t>SOLO EL HOMBRE DISTRIBUYE LA CARGA — ELLA YA LA TIENE ASIGNADA.</a:t>
             </a:r>
           </a:p>
         </p:txBody>
@@ -6254,6 +6534,41 @@
                 <a:latin typeface="Poppins"/>
               </a:rPr>
               <a:t> y 59.4% del estrato E responden "Madre". La carga se concentra donde no hay con quién repartirla.</a:t>
+            </a:r>
+          </a:p>
+        </p:txBody>
+      </p:sp>
+      <p:sp>
+        <p:nvSpPr>
+          <p:cNvPr id="11" name="TextBox 10"/>
+          <p:cNvSpPr txBox="1"/>
+          <p:nvPr/>
+        </p:nvSpPr>
+        <p:spPr>
+          <a:xfrm>
+            <a:off x="0" y="9620250"/>
+            <a:ext cx="18288000" cy="476250"/>
+          </a:xfrm>
+          <a:prstGeom prst="rect">
+            <a:avLst/>
+          </a:prstGeom>
+          <a:noFill/>
+        </p:spPr>
+        <p:txBody>
+          <a:bodyPr wrap="square" lIns="0" rIns="0" tIns="0" bIns="0">
+            <a:spAutoFit/>
+          </a:bodyPr>
+          <a:lstStyle/>
+          <a:p>
+            <a:pPr algn="ctr"/>
+            <a:r>
+              <a:rPr sz="1200" b="0" i="1" kern="0" spc="0">
+                <a:solidFill>
+                  <a:srgbClr val="9B9B9B"/>
+                </a:solidFill>
+                <a:latin typeface="Poppins"/>
+              </a:rPr>
+              <a:t>Source: Código Casa — Pilar Mujer · Q054 · Base 500.</a:t>
             </a:r>
           </a:p>
         </p:txBody>
@@ -6389,6 +6704,41 @@
           </a:p>
         </p:txBody>
       </p:sp>
+      <p:sp>
+        <p:nvSpPr>
+          <p:cNvPr id="5" name="TextBox 4"/>
+          <p:cNvSpPr txBox="1"/>
+          <p:nvPr/>
+        </p:nvSpPr>
+        <p:spPr>
+          <a:xfrm>
+            <a:off x="0" y="9620250"/>
+            <a:ext cx="18288000" cy="476250"/>
+          </a:xfrm>
+          <a:prstGeom prst="rect">
+            <a:avLst/>
+          </a:prstGeom>
+          <a:noFill/>
+        </p:spPr>
+        <p:txBody>
+          <a:bodyPr wrap="square" lIns="0" rIns="0" tIns="0" bIns="0">
+            <a:spAutoFit/>
+          </a:bodyPr>
+          <a:lstStyle/>
+          <a:p>
+            <a:pPr algn="ctr"/>
+            <a:r>
+              <a:rPr sz="1200" b="0" i="1" kern="0" spc="0">
+                <a:solidFill>
+                  <a:srgbClr val="9B9B9B"/>
+                </a:solidFill>
+                <a:latin typeface="Poppins"/>
+              </a:rPr>
+              <a:t>Source: Finance Women — Estudio cuantitativo 2025 · M20, M21 · Mujeres n=240.</a:t>
+            </a:r>
+          </a:p>
+        </p:txBody>
+      </p:sp>
     </p:spTree>
   </p:cSld>
   <p:clrMapOvr>
@@ -6445,7 +6795,7 @@
                 </a:solidFill>
                 <a:latin typeface="Instrument Serif"/>
               </a:rPr>
-              <a:t>74.9% SIENTE QUE ALGO LE BLOQUEA EL SUEÑO FINANCIERO. PARA 87.1% DE ELLAS ESE ALGO ES LA FALTA DE INGRESOS: </a:t>
+              <a:t>74.9% SIENTE QUE ALGO LE BLOQUEA EL SUEÑO FINANCIERO. </a:t>
             </a:r>
             <a:r>
               <a:rPr sz="5000" b="0" i="1" kern="0" spc="0">
@@ -6454,7 +6804,7 @@
                 </a:solidFill>
                 <a:latin typeface="Instrument Serif"/>
               </a:rPr>
-              <a:t>EL PROBLEMA NO ES LA DISCIPLINA, ES LA PLATA.</a:t>
+              <a:t>87.1% APUNTA A LO MISMO: FALTA PLATA.</a:t>
             </a:r>
           </a:p>
         </p:txBody>
@@ -6805,6 +7155,41 @@
                 <a:latin typeface="Poppins"/>
               </a:rPr>
               <a:t>" como lo que le impide tomar mejores decisiones financieras hoy.</a:t>
+            </a:r>
+          </a:p>
+        </p:txBody>
+      </p:sp>
+      <p:sp>
+        <p:nvSpPr>
+          <p:cNvPr id="11" name="TextBox 10"/>
+          <p:cNvSpPr txBox="1"/>
+          <p:nvPr/>
+        </p:nvSpPr>
+        <p:spPr>
+          <a:xfrm>
+            <a:off x="0" y="9620250"/>
+            <a:ext cx="18288000" cy="476250"/>
+          </a:xfrm>
+          <a:prstGeom prst="rect">
+            <a:avLst/>
+          </a:prstGeom>
+          <a:noFill/>
+        </p:spPr>
+        <p:txBody>
+          <a:bodyPr wrap="square" lIns="0" rIns="0" tIns="0" bIns="0">
+            <a:spAutoFit/>
+          </a:bodyPr>
+          <a:lstStyle/>
+          <a:p>
+            <a:pPr algn="ctr"/>
+            <a:r>
+              <a:rPr sz="1200" b="0" i="1" kern="0" spc="0">
+                <a:solidFill>
+                  <a:srgbClr val="9B9B9B"/>
+                </a:solidFill>
+                <a:latin typeface="Poppins"/>
+              </a:rPr>
+              <a:t>Source: Finance Women — Estudio cuantitativo 2025 · M23, M24, M54 · Mujeres n=240.</a:t>
             </a:r>
           </a:p>
         </p:txBody>
@@ -6940,6 +7325,41 @@
           </a:p>
         </p:txBody>
       </p:sp>
+      <p:sp>
+        <p:nvSpPr>
+          <p:cNvPr id="5" name="TextBox 4"/>
+          <p:cNvSpPr txBox="1"/>
+          <p:nvPr/>
+        </p:nvSpPr>
+        <p:spPr>
+          <a:xfrm>
+            <a:off x="0" y="9620250"/>
+            <a:ext cx="18288000" cy="476250"/>
+          </a:xfrm>
+          <a:prstGeom prst="rect">
+            <a:avLst/>
+          </a:prstGeom>
+          <a:noFill/>
+        </p:spPr>
+        <p:txBody>
+          <a:bodyPr wrap="square" lIns="0" rIns="0" tIns="0" bIns="0">
+            <a:spAutoFit/>
+          </a:bodyPr>
+          <a:lstStyle/>
+          <a:p>
+            <a:pPr algn="ctr"/>
+            <a:r>
+              <a:rPr sz="1200" b="0" i="1" kern="0" spc="0">
+                <a:solidFill>
+                  <a:srgbClr val="9B9B9B"/>
+                </a:solidFill>
+                <a:latin typeface="Poppins"/>
+              </a:rPr>
+              <a:t>Source: Finance Women — Estudio cuantitativo 2025 · M23, M24, M54 · Mujeres n=240.</a:t>
+            </a:r>
+          </a:p>
+        </p:txBody>
+      </p:sp>
     </p:spTree>
   </p:cSld>
   <p:clrMapOvr>
@@ -7005,7 +7425,7 @@
                 </a:solidFill>
                 <a:latin typeface="Instrument Serif"/>
               </a:rPr>
-              <a:t>LA ADMINISTRADORA NO ES EL ESTEREOTIPO: ES LA NORMA.</a:t>
+              <a:t>LA ADMINISTRADORA ES LA NORMA, NO LA EXCEPCIÓN.</a:t>
             </a:r>
           </a:p>
         </p:txBody>
@@ -7356,6 +7776,41 @@
                 <a:latin typeface="Poppins"/>
               </a:rPr>
               <a:t>" con el dinero y 20% como "Práctica"; solo 6.7% se define "Libre". La autopercepción es de control, no de derroche.</a:t>
+            </a:r>
+          </a:p>
+        </p:txBody>
+      </p:sp>
+      <p:sp>
+        <p:nvSpPr>
+          <p:cNvPr id="11" name="TextBox 10"/>
+          <p:cNvSpPr txBox="1"/>
+          <p:nvPr/>
+        </p:nvSpPr>
+        <p:spPr>
+          <a:xfrm>
+            <a:off x="0" y="9620250"/>
+            <a:ext cx="18288000" cy="476250"/>
+          </a:xfrm>
+          <a:prstGeom prst="rect">
+            <a:avLst/>
+          </a:prstGeom>
+          <a:noFill/>
+        </p:spPr>
+        <p:txBody>
+          <a:bodyPr wrap="square" lIns="0" rIns="0" tIns="0" bIns="0">
+            <a:spAutoFit/>
+          </a:bodyPr>
+          <a:lstStyle/>
+          <a:p>
+            <a:pPr algn="ctr"/>
+            <a:r>
+              <a:rPr sz="1200" b="0" i="1" kern="0" spc="0">
+                <a:solidFill>
+                  <a:srgbClr val="9B9B9B"/>
+                </a:solidFill>
+                <a:latin typeface="Poppins"/>
+              </a:rPr>
+              <a:t>Source: Finance Women — Estudio cuantitativo 2025 · M16, M28, M32, M60 · Mujeres n=240.</a:t>
             </a:r>
           </a:p>
         </p:txBody>
@@ -7491,6 +7946,41 @@
           </a:p>
         </p:txBody>
       </p:sp>
+      <p:sp>
+        <p:nvSpPr>
+          <p:cNvPr id="5" name="TextBox 4"/>
+          <p:cNvSpPr txBox="1"/>
+          <p:nvPr/>
+        </p:nvSpPr>
+        <p:spPr>
+          <a:xfrm>
+            <a:off x="0" y="9620250"/>
+            <a:ext cx="18288000" cy="476250"/>
+          </a:xfrm>
+          <a:prstGeom prst="rect">
+            <a:avLst/>
+          </a:prstGeom>
+          <a:noFill/>
+        </p:spPr>
+        <p:txBody>
+          <a:bodyPr wrap="square" lIns="0" rIns="0" tIns="0" bIns="0">
+            <a:spAutoFit/>
+          </a:bodyPr>
+          <a:lstStyle/>
+          <a:p>
+            <a:pPr algn="ctr"/>
+            <a:r>
+              <a:rPr sz="1200" b="0" i="1" kern="0" spc="0">
+                <a:solidFill>
+                  <a:srgbClr val="9B9B9B"/>
+                </a:solidFill>
+                <a:latin typeface="Poppins"/>
+              </a:rPr>
+              <a:t>Source: Finance Women — Estudio cuantitativo 2025 · M16, M28, M32, M60 · Mujeres n=240.</a:t>
+            </a:r>
+          </a:p>
+        </p:txBody>
+      </p:sp>
     </p:spTree>
   </p:cSld>
   <p:clrMapOvr>
@@ -7649,6 +8139,41 @@
           </a:p>
         </p:txBody>
       </p:sp>
+      <p:sp>
+        <p:nvSpPr>
+          <p:cNvPr id="5" name="TextBox 4"/>
+          <p:cNvSpPr txBox="1"/>
+          <p:nvPr/>
+        </p:nvSpPr>
+        <p:spPr>
+          <a:xfrm>
+            <a:off x="0" y="9620250"/>
+            <a:ext cx="18288000" cy="476250"/>
+          </a:xfrm>
+          <a:prstGeom prst="rect">
+            <a:avLst/>
+          </a:prstGeom>
+          <a:noFill/>
+        </p:spPr>
+        <p:txBody>
+          <a:bodyPr wrap="square" lIns="0" rIns="0" tIns="0" bIns="0">
+            <a:spAutoFit/>
+          </a:bodyPr>
+          <a:lstStyle/>
+          <a:p>
+            <a:pPr algn="ctr"/>
+            <a:r>
+              <a:rPr sz="1200" b="0" i="1" kern="0" spc="0">
+                <a:solidFill>
+                  <a:srgbClr val="9B9B9B"/>
+                </a:solidFill>
+                <a:latin typeface="Poppins"/>
+              </a:rPr>
+              <a:t>Source: Finance Women — Estudio cuantitativo 2025 · M45, M45b · Mujeres n=240.</a:t>
+            </a:r>
+          </a:p>
+        </p:txBody>
+      </p:sp>
     </p:spTree>
   </p:cSld>
   <p:clrMapOvr>
@@ -7919,6 +8444,41 @@
           </a:p>
         </p:txBody>
       </p:sp>
+      <p:sp>
+        <p:nvSpPr>
+          <p:cNvPr id="7" name="TextBox 6"/>
+          <p:cNvSpPr txBox="1"/>
+          <p:nvPr/>
+        </p:nvSpPr>
+        <p:spPr>
+          <a:xfrm>
+            <a:off x="0" y="9620250"/>
+            <a:ext cx="18288000" cy="476250"/>
+          </a:xfrm>
+          <a:prstGeom prst="rect">
+            <a:avLst/>
+          </a:prstGeom>
+          <a:noFill/>
+        </p:spPr>
+        <p:txBody>
+          <a:bodyPr wrap="square" lIns="0" rIns="0" tIns="0" bIns="0">
+            <a:spAutoFit/>
+          </a:bodyPr>
+          <a:lstStyle/>
+          <a:p>
+            <a:pPr algn="ctr"/>
+            <a:r>
+              <a:rPr sz="1200" b="0" i="1" kern="0" spc="0">
+                <a:solidFill>
+                  <a:srgbClr val="9B9B9B"/>
+                </a:solidFill>
+                <a:latin typeface="Poppins"/>
+              </a:rPr>
+              <a:t>Source: Finance Women — Estudio cuantitativo 2025 · M45, M45b · Mujeres n=240.</a:t>
+            </a:r>
+          </a:p>
+        </p:txBody>
+      </p:sp>
     </p:spTree>
   </p:cSld>
   <p:clrMapOvr>
@@ -8115,7 +8675,7 @@
                 </a:solidFill>
                 <a:latin typeface="Instrument Serif"/>
               </a:rPr>
-              <a:t>EL ORGULLO SOLO LLEGA AL 5.5%: EL DINERO NO SE VIVE COMO LOGRO, SE VIVE COMO AMENAZA.</a:t>
+              <a:t>EL ORGULLO SOLO LLEGA AL 5.5%: EL DINERO SE VIVE COMO AMENAZA, NO COMO LOGRO.</a:t>
             </a:r>
           </a:p>
         </p:txBody>
@@ -8466,6 +9026,41 @@
                 <a:latin typeface="Poppins"/>
               </a:rPr>
               <a:t>); 30.8% está insatisfecha (bottom-2). El promedio es 2.75 sobre 5.</a:t>
+            </a:r>
+          </a:p>
+        </p:txBody>
+      </p:sp>
+      <p:sp>
+        <p:nvSpPr>
+          <p:cNvPr id="11" name="TextBox 10"/>
+          <p:cNvSpPr txBox="1"/>
+          <p:nvPr/>
+        </p:nvSpPr>
+        <p:spPr>
+          <a:xfrm>
+            <a:off x="0" y="9620250"/>
+            <a:ext cx="18288000" cy="476250"/>
+          </a:xfrm>
+          <a:prstGeom prst="rect">
+            <a:avLst/>
+          </a:prstGeom>
+          <a:noFill/>
+        </p:spPr>
+        <p:txBody>
+          <a:bodyPr wrap="square" lIns="0" rIns="0" tIns="0" bIns="0">
+            <a:spAutoFit/>
+          </a:bodyPr>
+          <a:lstStyle/>
+          <a:p>
+            <a:pPr algn="ctr"/>
+            <a:r>
+              <a:rPr sz="1200" b="0" i="1" kern="0" spc="0">
+                <a:solidFill>
+                  <a:srgbClr val="9B9B9B"/>
+                </a:solidFill>
+                <a:latin typeface="Poppins"/>
+              </a:rPr>
+              <a:t>Source: Finance Women — Estudio cuantitativo 2025 · M19, M43, M44 · Mujeres n=240.</a:t>
             </a:r>
           </a:p>
         </p:txBody>
@@ -8601,6 +9196,41 @@
           </a:p>
         </p:txBody>
       </p:sp>
+      <p:sp>
+        <p:nvSpPr>
+          <p:cNvPr id="5" name="TextBox 4"/>
+          <p:cNvSpPr txBox="1"/>
+          <p:nvPr/>
+        </p:nvSpPr>
+        <p:spPr>
+          <a:xfrm>
+            <a:off x="0" y="9620250"/>
+            <a:ext cx="18288000" cy="476250"/>
+          </a:xfrm>
+          <a:prstGeom prst="rect">
+            <a:avLst/>
+          </a:prstGeom>
+          <a:noFill/>
+        </p:spPr>
+        <p:txBody>
+          <a:bodyPr wrap="square" lIns="0" rIns="0" tIns="0" bIns="0">
+            <a:spAutoFit/>
+          </a:bodyPr>
+          <a:lstStyle/>
+          <a:p>
+            <a:pPr algn="ctr"/>
+            <a:r>
+              <a:rPr sz="1200" b="0" i="1" kern="0" spc="0">
+                <a:solidFill>
+                  <a:srgbClr val="9B9B9B"/>
+                </a:solidFill>
+                <a:latin typeface="Poppins"/>
+              </a:rPr>
+              <a:t>Source: Finance Women — Estudio cuantitativo 2025 · M19, M43, M44 · Mujeres n=240.</a:t>
+            </a:r>
+          </a:p>
+        </p:txBody>
+      </p:sp>
     </p:spTree>
   </p:cSld>
   <p:clrMapOvr>
@@ -8732,6 +9362,41 @@
           </a:p>
         </p:txBody>
       </p:sp>
+      <p:sp>
+        <p:nvSpPr>
+          <p:cNvPr id="5" name="TextBox 4"/>
+          <p:cNvSpPr txBox="1"/>
+          <p:nvPr/>
+        </p:nvSpPr>
+        <p:spPr>
+          <a:xfrm>
+            <a:off x="0" y="9620250"/>
+            <a:ext cx="18288000" cy="476250"/>
+          </a:xfrm>
+          <a:prstGeom prst="rect">
+            <a:avLst/>
+          </a:prstGeom>
+          <a:noFill/>
+        </p:spPr>
+        <p:txBody>
+          <a:bodyPr wrap="square" lIns="0" rIns="0" tIns="0" bIns="0">
+            <a:spAutoFit/>
+          </a:bodyPr>
+          <a:lstStyle/>
+          <a:p>
+            <a:pPr algn="ctr"/>
+            <a:r>
+              <a:rPr sz="1200" b="0" i="1" kern="0" spc="0">
+                <a:solidFill>
+                  <a:srgbClr val="9B9B9B"/>
+                </a:solidFill>
+                <a:latin typeface="Poppins"/>
+              </a:rPr>
+              <a:t>Source: Código Casa — Pilar Mujer · Q054 · Base 500.</a:t>
+            </a:r>
+          </a:p>
+        </p:txBody>
+      </p:sp>
     </p:spTree>
   </p:cSld>
   <p:clrMapOvr>
@@ -8788,7 +9453,7 @@
                 </a:solidFill>
                 <a:latin typeface="Instrument Serif"/>
               </a:rPr>
-              <a:t>47.9% HIZO UNA COMPRA IMPULSIVA EL ÚLTIMO MES. EL MOTIVO #1 NO ES LA PROMOCIÓN: </a:t>
+              <a:t>47.9% HIZO UNA COMPRA IMPULSIVA EL ÚLTIMO MES. </a:t>
             </a:r>
             <a:r>
               <a:rPr sz="5000" b="0" i="1" kern="0" spc="0">
@@ -8797,7 +9462,7 @@
                 </a:solidFill>
                 <a:latin typeface="Instrument Serif"/>
               </a:rPr>
-              <a:t>ES CONSENTIRSE, PORQUE EL ROL NO DEJA OTRO ESPACIO PARA HACERLO.</a:t>
+              <a:t>EL MOTIVO #1 ES CONSENTIRSE — EL ÚNICO ESPACIO QUE EL ROL LE DEJA SOLO PARA ELLA.</a:t>
             </a:r>
           </a:p>
         </p:txBody>
@@ -9147,7 +9812,42 @@
                 </a:solidFill>
                 <a:latin typeface="Poppins"/>
               </a:rPr>
-              <a:t>" y 59.8% "Ropa/Accesorios"; "Electrónica" apenas 5.0%. No es derroche aspiracional: es desahogo de día a día.</a:t>
+              <a:t>" y 59.8% "Ropa/Accesorios"; "Electrónica" apenas 5.0%. Desahogo de día a día, no derroche aspiracional.</a:t>
+            </a:r>
+          </a:p>
+        </p:txBody>
+      </p:sp>
+      <p:sp>
+        <p:nvSpPr>
+          <p:cNvPr id="11" name="TextBox 10"/>
+          <p:cNvSpPr txBox="1"/>
+          <p:nvPr/>
+        </p:nvSpPr>
+        <p:spPr>
+          <a:xfrm>
+            <a:off x="0" y="9620250"/>
+            <a:ext cx="18288000" cy="476250"/>
+          </a:xfrm>
+          <a:prstGeom prst="rect">
+            <a:avLst/>
+          </a:prstGeom>
+          <a:noFill/>
+        </p:spPr>
+        <p:txBody>
+          <a:bodyPr wrap="square" lIns="0" rIns="0" tIns="0" bIns="0">
+            <a:spAutoFit/>
+          </a:bodyPr>
+          <a:lstStyle/>
+          <a:p>
+            <a:pPr algn="ctr"/>
+            <a:r>
+              <a:rPr sz="1200" b="0" i="1" kern="0" spc="0">
+                <a:solidFill>
+                  <a:srgbClr val="9B9B9B"/>
+                </a:solidFill>
+                <a:latin typeface="Poppins"/>
+              </a:rPr>
+              <a:t>Source: Finance Women — Estudio cuantitativo 2025 · M33, M34, M36, M37 · Mujeres n=240.</a:t>
             </a:r>
           </a:p>
         </p:txBody>
@@ -9283,6 +9983,41 @@
           </a:p>
         </p:txBody>
       </p:sp>
+      <p:sp>
+        <p:nvSpPr>
+          <p:cNvPr id="5" name="TextBox 4"/>
+          <p:cNvSpPr txBox="1"/>
+          <p:nvPr/>
+        </p:nvSpPr>
+        <p:spPr>
+          <a:xfrm>
+            <a:off x="0" y="9620250"/>
+            <a:ext cx="18288000" cy="476250"/>
+          </a:xfrm>
+          <a:prstGeom prst="rect">
+            <a:avLst/>
+          </a:prstGeom>
+          <a:noFill/>
+        </p:spPr>
+        <p:txBody>
+          <a:bodyPr wrap="square" lIns="0" rIns="0" tIns="0" bIns="0">
+            <a:spAutoFit/>
+          </a:bodyPr>
+          <a:lstStyle/>
+          <a:p>
+            <a:pPr algn="ctr"/>
+            <a:r>
+              <a:rPr sz="1200" b="0" i="1" kern="0" spc="0">
+                <a:solidFill>
+                  <a:srgbClr val="9B9B9B"/>
+                </a:solidFill>
+                <a:latin typeface="Poppins"/>
+              </a:rPr>
+              <a:t>Source: Finance Women — Estudio cuantitativo 2025 · M33, M34, M36, M37 · Mujeres n=240.</a:t>
+            </a:r>
+          </a:p>
+        </p:txBody>
+      </p:sp>
     </p:spTree>
   </p:cSld>
   <p:clrMapOvr>
@@ -9698,7 +10433,42 @@
                 </a:solidFill>
                 <a:latin typeface="Poppins"/>
               </a:rPr>
-              <a:t>" es el obstáculo #1 (65.5%), por encima de "Falta de educación financiera" (58.4%). El problema es estructural.</a:t>
+              <a:t>" es el obstáculo #1 (65.5%), por encima de "Falta de educación financiera" (58.4%). La brecha de ahorro es de ingresos, no de conocimiento.</a:t>
+            </a:r>
+          </a:p>
+        </p:txBody>
+      </p:sp>
+      <p:sp>
+        <p:nvSpPr>
+          <p:cNvPr id="11" name="TextBox 10"/>
+          <p:cNvSpPr txBox="1"/>
+          <p:nvPr/>
+        </p:nvSpPr>
+        <p:spPr>
+          <a:xfrm>
+            <a:off x="0" y="9620250"/>
+            <a:ext cx="18288000" cy="476250"/>
+          </a:xfrm>
+          <a:prstGeom prst="rect">
+            <a:avLst/>
+          </a:prstGeom>
+          <a:noFill/>
+        </p:spPr>
+        <p:txBody>
+          <a:bodyPr wrap="square" lIns="0" rIns="0" tIns="0" bIns="0">
+            <a:spAutoFit/>
+          </a:bodyPr>
+          <a:lstStyle/>
+          <a:p>
+            <a:pPr algn="ctr"/>
+            <a:r>
+              <a:rPr sz="1200" b="0" i="1" kern="0" spc="0">
+                <a:solidFill>
+                  <a:srgbClr val="9B9B9B"/>
+                </a:solidFill>
+                <a:latin typeface="Poppins"/>
+              </a:rPr>
+              <a:t>Source: Finance Women — Estudio cuantitativo 2025 · M38, M39, M40, M61 · Mujeres n=240.</a:t>
             </a:r>
           </a:p>
         </p:txBody>
@@ -9973,6 +10743,41 @@
           </a:p>
         </p:txBody>
       </p:sp>
+      <p:sp>
+        <p:nvSpPr>
+          <p:cNvPr id="7" name="TextBox 6"/>
+          <p:cNvSpPr txBox="1"/>
+          <p:nvPr/>
+        </p:nvSpPr>
+        <p:spPr>
+          <a:xfrm>
+            <a:off x="0" y="9620250"/>
+            <a:ext cx="18288000" cy="476250"/>
+          </a:xfrm>
+          <a:prstGeom prst="rect">
+            <a:avLst/>
+          </a:prstGeom>
+          <a:noFill/>
+        </p:spPr>
+        <p:txBody>
+          <a:bodyPr wrap="square" lIns="0" rIns="0" tIns="0" bIns="0">
+            <a:spAutoFit/>
+          </a:bodyPr>
+          <a:lstStyle/>
+          <a:p>
+            <a:pPr algn="ctr"/>
+            <a:r>
+              <a:rPr sz="1200" b="0" i="1" kern="0" spc="0">
+                <a:solidFill>
+                  <a:srgbClr val="9B9B9B"/>
+                </a:solidFill>
+                <a:latin typeface="Poppins"/>
+              </a:rPr>
+              <a:t>Source: Finance Women — Estudio cuantitativo 2025 · M38, M39, M40, M61 · Mujeres n=240.</a:t>
+            </a:r>
+          </a:p>
+        </p:txBody>
+      </p:sp>
     </p:spTree>
   </p:cSld>
   <p:clrMapOvr>
@@ -10393,6 +11198,41 @@
           </a:p>
         </p:txBody>
       </p:sp>
+      <p:sp>
+        <p:nvSpPr>
+          <p:cNvPr id="11" name="TextBox 10"/>
+          <p:cNvSpPr txBox="1"/>
+          <p:nvPr/>
+        </p:nvSpPr>
+        <p:spPr>
+          <a:xfrm>
+            <a:off x="0" y="9620250"/>
+            <a:ext cx="18288000" cy="476250"/>
+          </a:xfrm>
+          <a:prstGeom prst="rect">
+            <a:avLst/>
+          </a:prstGeom>
+          <a:noFill/>
+        </p:spPr>
+        <p:txBody>
+          <a:bodyPr wrap="square" lIns="0" rIns="0" tIns="0" bIns="0">
+            <a:spAutoFit/>
+          </a:bodyPr>
+          <a:lstStyle/>
+          <a:p>
+            <a:pPr algn="ctr"/>
+            <a:r>
+              <a:rPr sz="1200" b="0" i="1" kern="0" spc="0">
+                <a:solidFill>
+                  <a:srgbClr val="9B9B9B"/>
+                </a:solidFill>
+                <a:latin typeface="Poppins"/>
+              </a:rPr>
+              <a:t>Source: Código Casa — Pilar Mujer · Q056 · Base 500.</a:t>
+            </a:r>
+          </a:p>
+        </p:txBody>
+      </p:sp>
     </p:spTree>
   </p:cSld>
   <p:clrMapOvr>
@@ -10524,6 +11364,41 @@
           </a:p>
         </p:txBody>
       </p:sp>
+      <p:sp>
+        <p:nvSpPr>
+          <p:cNvPr id="5" name="TextBox 4"/>
+          <p:cNvSpPr txBox="1"/>
+          <p:nvPr/>
+        </p:nvSpPr>
+        <p:spPr>
+          <a:xfrm>
+            <a:off x="0" y="9620250"/>
+            <a:ext cx="18288000" cy="476250"/>
+          </a:xfrm>
+          <a:prstGeom prst="rect">
+            <a:avLst/>
+          </a:prstGeom>
+          <a:noFill/>
+        </p:spPr>
+        <p:txBody>
+          <a:bodyPr wrap="square" lIns="0" rIns="0" tIns="0" bIns="0">
+            <a:spAutoFit/>
+          </a:bodyPr>
+          <a:lstStyle/>
+          <a:p>
+            <a:pPr algn="ctr"/>
+            <a:r>
+              <a:rPr sz="1200" b="0" i="1" kern="0" spc="0">
+                <a:solidFill>
+                  <a:srgbClr val="9B9B9B"/>
+                </a:solidFill>
+                <a:latin typeface="Poppins"/>
+              </a:rPr>
+              <a:t>Source: Código Casa — Pilar Mujer · Q056 · Base 500.</a:t>
+            </a:r>
+          </a:p>
+        </p:txBody>
+      </p:sp>
     </p:spTree>
   </p:cSld>
   <p:clrMapOvr>
@@ -10944,6 +11819,41 @@
           </a:p>
         </p:txBody>
       </p:sp>
+      <p:sp>
+        <p:nvSpPr>
+          <p:cNvPr id="11" name="TextBox 10"/>
+          <p:cNvSpPr txBox="1"/>
+          <p:nvPr/>
+        </p:nvSpPr>
+        <p:spPr>
+          <a:xfrm>
+            <a:off x="0" y="9620250"/>
+            <a:ext cx="18288000" cy="476250"/>
+          </a:xfrm>
+          <a:prstGeom prst="rect">
+            <a:avLst/>
+          </a:prstGeom>
+          <a:noFill/>
+        </p:spPr>
+        <p:txBody>
+          <a:bodyPr wrap="square" lIns="0" rIns="0" tIns="0" bIns="0">
+            <a:spAutoFit/>
+          </a:bodyPr>
+          <a:lstStyle/>
+          <a:p>
+            <a:pPr algn="ctr"/>
+            <a:r>
+              <a:rPr sz="1200" b="0" i="1" kern="0" spc="0">
+                <a:solidFill>
+                  <a:srgbClr val="9B9B9B"/>
+                </a:solidFill>
+                <a:latin typeface="Poppins"/>
+              </a:rPr>
+              <a:t>Source: Código Casa — Pilar Mujer · Q060 · Base 500.</a:t>
+            </a:r>
+          </a:p>
+        </p:txBody>
+      </p:sp>
     </p:spTree>
   </p:cSld>
   <p:clrMapOvr>
@@ -11075,6 +11985,41 @@
           </a:p>
         </p:txBody>
       </p:sp>
+      <p:sp>
+        <p:nvSpPr>
+          <p:cNvPr id="5" name="TextBox 4"/>
+          <p:cNvSpPr txBox="1"/>
+          <p:nvPr/>
+        </p:nvSpPr>
+        <p:spPr>
+          <a:xfrm>
+            <a:off x="0" y="9620250"/>
+            <a:ext cx="18288000" cy="476250"/>
+          </a:xfrm>
+          <a:prstGeom prst="rect">
+            <a:avLst/>
+          </a:prstGeom>
+          <a:noFill/>
+        </p:spPr>
+        <p:txBody>
+          <a:bodyPr wrap="square" lIns="0" rIns="0" tIns="0" bIns="0">
+            <a:spAutoFit/>
+          </a:bodyPr>
+          <a:lstStyle/>
+          <a:p>
+            <a:pPr algn="ctr"/>
+            <a:r>
+              <a:rPr sz="1200" b="0" i="1" kern="0" spc="0">
+                <a:solidFill>
+                  <a:srgbClr val="9B9B9B"/>
+                </a:solidFill>
+                <a:latin typeface="Poppins"/>
+              </a:rPr>
+              <a:t>Source: Código Casa — Pilar Mujer · Q060 · Base 500.</a:t>
+            </a:r>
+          </a:p>
+        </p:txBody>
+      </p:sp>
     </p:spTree>
   </p:cSld>
   <p:clrMapOvr>
@@ -11201,7 +12146,7 @@
                 </a:solidFill>
                 <a:latin typeface="Poppins"/>
               </a:rPr>
-              <a:t>74.8% dice que los roles cambiaron mucho. Las tareas domésticas no se enteraron.</a:t>
+              <a:t>74.8% dice que los roles cambiaron mucho. Las tareas domésticas siguieron siendo de ella.</a:t>
             </a:r>
           </a:p>
         </p:txBody>
@@ -11262,7 +12207,7 @@
                 </a:solidFill>
                 <a:latin typeface="Instrument Serif"/>
               </a:rPr>
-              <a:t>74.8% DICE QUE EL ROL DE GÉNERO CAMBIÓ MUCHO. LA COCINA, EL LAVADO Y LA LIMPIEZA NO SE ENTERARON: </a:t>
+              <a:t>74.8% DICE QUE EL ROL DE GÉNERO CAMBIÓ MUCHO. LA COCINA, EL LAVADO Y LA LIMPIEZA SIGUIERON SIENDO DE ELLA. </a:t>
             </a:r>
             <a:r>
               <a:rPr sz="5000" b="0" i="1" kern="0" spc="0">
@@ -11271,7 +12216,7 @@
                 </a:solidFill>
                 <a:latin typeface="Instrument Serif"/>
               </a:rPr>
-              <a:t>EL CAMBIO ES DE DISCURSO, NO DE REPARTO.</a:t>
+              <a:t>EL DISCURSO AVANZÓ; EL REPARTO, NO.</a:t>
             </a:r>
           </a:p>
         </p:txBody>
@@ -11621,7 +12566,42 @@
                 </a:solidFill>
                 <a:latin typeface="Poppins"/>
               </a:rPr>
-              <a:t> (Q056). Convive con la percepción de cambio (Q057). El reparto material no acompaña la narrativa.</a:t>
+              <a:t> (Q056). Convive con la percepción de cambio (Q057). El reparto material no acompaña la percepción.</a:t>
+            </a:r>
+          </a:p>
+        </p:txBody>
+      </p:sp>
+      <p:sp>
+        <p:nvSpPr>
+          <p:cNvPr id="11" name="TextBox 10"/>
+          <p:cNvSpPr txBox="1"/>
+          <p:nvPr/>
+        </p:nvSpPr>
+        <p:spPr>
+          <a:xfrm>
+            <a:off x="0" y="9620250"/>
+            <a:ext cx="18288000" cy="476250"/>
+          </a:xfrm>
+          <a:prstGeom prst="rect">
+            <a:avLst/>
+          </a:prstGeom>
+          <a:noFill/>
+        </p:spPr>
+        <p:txBody>
+          <a:bodyPr wrap="square" lIns="0" rIns="0" tIns="0" bIns="0">
+            <a:spAutoFit/>
+          </a:bodyPr>
+          <a:lstStyle/>
+          <a:p>
+            <a:pPr algn="ctr"/>
+            <a:r>
+              <a:rPr sz="1200" b="0" i="1" kern="0" spc="0">
+                <a:solidFill>
+                  <a:srgbClr val="9B9B9B"/>
+                </a:solidFill>
+                <a:latin typeface="Poppins"/>
+              </a:rPr>
+              <a:t>Source: Código Casa — Pilar Mujer · Q057, Q056 · Base 500.</a:t>
             </a:r>
           </a:p>
         </p:txBody>

</xml_diff>